<commit_message>
Teste de OLS no conjunto de dados
</commit_message>
<xml_diff>
--- a/.documetosProjeto/Aula_9_-_Checkpoint_1_-_Trabalho_de_Extensao-69dc2716951f3.pptx
+++ b/.documetosProjeto/Aula_9_-_Checkpoint_1_-_Trabalho_de_Extensao-69dc2716951f3.pptx
@@ -169,6 +169,15 @@
     </pc:docChg>
   </pc:docChgLst>
   <pc:docChgLst>
+    <pc:chgData name="Fabio Bittencourt" userId="9399af9f441dfb25" providerId="Windows Live" clId="Web-{929FFA45-AD16-8426-4576-15CAB10173A6}"/>
+    <pc:docChg chg="modSld">
+      <pc:chgData name="Fabio Bittencourt" userId="9399af9f441dfb25" providerId="Windows Live" clId="Web-{929FFA45-AD16-8426-4576-15CAB10173A6}" dt="2026-04-02T16:56:02.753" v="3" actId="20577"/>
+      <pc:docMkLst>
+        <pc:docMk/>
+      </pc:docMkLst>
+    </pc:docChg>
+  </pc:docChgLst>
+  <pc:docChgLst>
     <pc:chgData name="Fabio Bittencourt" userId="9399af9f441dfb25" providerId="LiveId" clId="{87FEEC51-4A4D-4000-AFF7-19B075429E2B}"/>
     <pc:docChg chg="undo redo custSel addSld delSld modSld sldOrd">
       <pc:chgData name="Fabio Bittencourt" userId="9399af9f441dfb25" providerId="LiveId" clId="{87FEEC51-4A4D-4000-AFF7-19B075429E2B}" dt="2026-04-12T23:07:59.095" v="22257" actId="20577"/>
@@ -810,15 +819,6 @@
     <pc:chgData name="Fabio Bittencourt" userId="9399af9f441dfb25" providerId="Windows Live" clId="Web-{DAD84DB3-91C5-7848-65C5-5D5604D12E2F}"/>
     <pc:docChg chg="addSld delSld modSld sldOrd">
       <pc:chgData name="Fabio Bittencourt" userId="9399af9f441dfb25" providerId="Windows Live" clId="Web-{DAD84DB3-91C5-7848-65C5-5D5604D12E2F}" dt="2026-03-22T18:44:50.718" v="2106" actId="20577"/>
-      <pc:docMkLst>
-        <pc:docMk/>
-      </pc:docMkLst>
-    </pc:docChg>
-  </pc:docChgLst>
-  <pc:docChgLst>
-    <pc:chgData name="Fabio Bittencourt" userId="9399af9f441dfb25" providerId="Windows Live" clId="Web-{929FFA45-AD16-8426-4576-15CAB10173A6}"/>
-    <pc:docChg chg="modSld">
-      <pc:chgData name="Fabio Bittencourt" userId="9399af9f441dfb25" providerId="Windows Live" clId="Web-{929FFA45-AD16-8426-4576-15CAB10173A6}" dt="2026-04-02T16:56:02.753" v="3" actId="20577"/>
       <pc:docMkLst>
         <pc:docMk/>
       </pc:docMkLst>
@@ -909,7 +909,7 @@
           <a:p>
             <a:fld id="{CB9ED787-ECF9-4317-9B3F-01368C487912}" type="datetimeFigureOut">
               <a:rPr lang="pt-BR" smtClean="0"/>
-              <a:t>12/04/2026</a:t>
+              <a:t>12/05/2026</a:t>
             </a:fld>
             <a:endParaRPr lang="pt-BR"/>
           </a:p>
@@ -4183,6 +4183,9 @@
                 <a:solidFill>
                   <a:srgbClr val="003958"/>
                 </a:solidFill>
+                <a:highlight>
+                  <a:srgbClr val="FFFF00"/>
+                </a:highlight>
                 <a:ea typeface="Calibri" panose="020F0502020204030204"/>
                 <a:cs typeface="Calibri" panose="020F0502020204030204"/>
               </a:rPr>
@@ -4215,17 +4218,7 @@
                 <a:ea typeface="Calibri" panose="020F0502020204030204"/>
                 <a:cs typeface="Calibri" panose="020F0502020204030204"/>
               </a:rPr>
-              <a:t>Após os passos anteriores, mostrar ao professor novamente, estando tudo certo </a:t>
-            </a:r>
-            <a:r>
-              <a:rPr lang="pt-BR">
-                <a:solidFill>
-                  <a:srgbClr val="003958"/>
-                </a:solidFill>
-                <a:ea typeface="Calibri" panose="020F0502020204030204"/>
-                <a:cs typeface="Calibri" panose="020F0502020204030204"/>
-              </a:rPr>
-              <a:t>estão dispensados.</a:t>
+              <a:t>Após os passos anteriores, mostrar ao professor novamente, estando tudo certo estão dispensados.</a:t>
             </a:r>
             <a:endParaRPr lang="pt-BR" sz="2000" dirty="0">
               <a:solidFill>
@@ -4307,11 +4300,11 @@
   <p:clrMapOvr>
     <a:masterClrMapping/>
   </p:clrMapOvr>
-  <mc:AlternateContent xmlns:mc="http://schemas.openxmlformats.org/markup-compatibility/2006">
-    <mc:Choice xmlns:p14="http://schemas.microsoft.com/office/powerpoint/2010/main" Requires="p14">
+  <mc:AlternateContent xmlns:mc="http://schemas.openxmlformats.org/markup-compatibility/2006" xmlns:p14="http://schemas.microsoft.com/office/powerpoint/2010/main">
+    <mc:Choice Requires="p14">
       <p:transition spd="slow" p14:dur="2000" advTm="191385"/>
     </mc:Choice>
-    <mc:Fallback>
+    <mc:Fallback xmlns="">
       <p:transition spd="slow" advTm="191385"/>
     </mc:Fallback>
   </mc:AlternateContent>

</xml_diff>